<commit_message>
Explain the logic of each control mode in the presentation
Slide 6 now gives each of the four modes a short description and the
logic behind it, matching the firmware in line_controller.cpp.

Claude-Session: https://claude.ai/code/session_01KU8aCf3zzAsNP6oUkmmfPM
</commit_message>
<xml_diff>
--- a/deck/line_follower_blueprint.pptx
+++ b/deck/line_follower_blueprint.pptx
@@ -123,30 +123,30 @@
   <p:extLst>
     <p:ext uri="{521415D9-36F7-43E2-AB2F-B90AF26B5E84}">
       <p14:sectionLst xmlns:p14="http://schemas.microsoft.com/office/powerpoint/2010/main">
-        <p14:section name="Start" id="{4212a323-a66f-7f75-56c2-95d346a5d4b6}">
+        <p14:section name="Start" id="{2a3d5dfb-8344-8657-bc00-bba1b5b39333}">
           <p14:sldIdLst>
             <p14:sldId id="256"/>
           </p14:sldIdLst>
         </p14:section>
-        <p14:section name="Idea" id="{21233f5f-2870-8780-73e6-71a65a075829}">
+        <p14:section name="Idea" id="{c0dc2cba-0a76-c6a2-f87a-6a55b73c8847}">
           <p14:sldIdLst>
             <p14:sldId id="257"/>
             <p14:sldId id="258"/>
           </p14:sldIdLst>
         </p14:section>
-        <p14:section name="Robot" id="{f4d6d9ec-db5d-4027-9a07-c3ddd975c175}">
+        <p14:section name="Robot" id="{6d0c815d-c531-a8a8-97e0-7835552e7030}">
           <p14:sldIdLst>
             <p14:sldId id="259"/>
             <p14:sldId id="260"/>
           </p14:sldIdLst>
         </p14:section>
-        <p14:section name="Driving" id="{30c04ae7-4043-a6d3-9c63-c430be22a1b4}">
+        <p14:section name="Driving" id="{9043f5ee-059b-b8fa-fb18-80917763aa1c}">
           <p14:sldIdLst>
             <p14:sldId id="261"/>
             <p14:sldId id="262"/>
           </p14:sldIdLst>
         </p14:section>
-        <p14:section name="Calculations" id="{1600b080-8797-1808-1fee-b82750973b13}">
+        <p14:section name="Calculations" id="{df7f8d23-3fc4-078f-e7a1-b1c87627d2f0}">
           <p14:sldIdLst>
             <p14:sldId id="263"/>
             <p14:sldId id="264"/>
@@ -155,22 +155,22 @@
             <p14:sldId id="267"/>
           </p14:sldIdLst>
         </p14:section>
-        <p14:section name="Double IR" id="{a5c3892c-844c-e197-3cd1-54208b78cf0e}">
+        <p14:section name="Double IR" id="{51b60984-8958-05df-c30e-6702cbb500cf}">
           <p14:sldIdLst>
             <p14:sldId id="268"/>
           </p14:sldIdLst>
         </p14:section>
-        <p14:section name="Results" id="{cbf1e0c8-08bf-28c5-1475-75466b4239b7}">
+        <p14:section name="Results" id="{4906e562-a8ae-c048-4df6-849c936413bf}">
           <p14:sldIdLst>
             <p14:sldId id="269"/>
           </p14:sldIdLst>
         </p14:section>
-        <p14:section name="Simulator" id="{219a240a-c703-2d1e-3825-e14484fdb493}">
+        <p14:section name="Simulator" id="{b05f5183-8675-d310-919f-b36ea2de78c0}">
           <p14:sldIdLst>
             <p14:sldId id="270"/>
           </p14:sldIdLst>
         </p14:section>
-        <p14:section name="Proof" id="{30002ee7-89e4-7c6d-9d31-51c25e6f42e8}">
+        <p14:section name="Proof" id="{67b7a74b-1757-eaaf-4a9b-7b648928ee71}">
           <p14:sldIdLst>
             <p14:sldId id="271"/>
             <p14:sldId id="272"/>
@@ -11390,8 +11390,8 @@
         </p:nvSpPr>
         <p:spPr>
           <a:xfrm>
-            <a:off x="548640" y="1645920"/>
-            <a:ext cx="5440680" cy="2286000"/>
+            <a:off x="548640" y="1554480"/>
+            <a:ext cx="5440680" cy="2377440"/>
           </a:xfrm>
           <a:prstGeom prst="rect">
             <a:avLst/>
@@ -11415,7 +11415,7 @@
         </p:nvSpPr>
         <p:spPr>
           <a:xfrm>
-            <a:off x="777240" y="1828800"/>
+            <a:off x="777240" y="1737360"/>
             <a:ext cx="4983480" cy="411480"/>
           </a:xfrm>
           <a:prstGeom prst="rect">
@@ -11454,8 +11454,8 @@
         </p:nvSpPr>
         <p:spPr>
           <a:xfrm>
-            <a:off x="777240" y="2331720"/>
-            <a:ext cx="4983480" cy="1417320"/>
+            <a:off x="777240" y="2240280"/>
+            <a:ext cx="4983480" cy="1508760"/>
           </a:xfrm>
           <a:prstGeom prst="rect">
             <a:avLst/>
@@ -11468,20 +11468,17 @@
           <a:lstStyle/>
           <a:p>
             <a:pPr indent="0" marL="0">
-              <a:spcAft>
-                <a:spcPts val="800"/>
-              </a:spcAft>
-              <a:buNone/>
-            </a:pPr>
-            <a:r>
-              <a:rPr lang="en-US" sz="1600" dirty="0">
+              <a:buNone/>
+            </a:pPr>
+            <a:r>
+              <a:rPr lang="en-US" sz="1400" dirty="0">
                 <a:solidFill>
                   <a:schemeClr val="tx2"/>
                 </a:solidFill>
               </a:rPr>
-              <a:t>Looks only at the sensors and steers back toward the line. It has no map so it cannot slow down before a corner.</a:t>
-            </a:r>
-            <a:endParaRPr lang="en-US" sz="1600" dirty="0"/>
+              <a:t>Steers only from the five IR sensors. No map. Logic: the sensors give how far the line is from the centre. A PID steering loop turns that error into a turn rate, and the robot slows when steering effort or error grows, so it eases off before it loses the line.</a:t>
+            </a:r>
+            <a:endParaRPr lang="en-US" sz="1400" dirty="0"/>
           </a:p>
         </p:txBody>
       </p:sp>
@@ -11493,8 +11490,8 @@
         </p:nvSpPr>
         <p:spPr>
           <a:xfrm>
-            <a:off x="6172200" y="1645920"/>
-            <a:ext cx="5440680" cy="2286000"/>
+            <a:off x="6172200" y="1554480"/>
+            <a:ext cx="5440680" cy="2377440"/>
           </a:xfrm>
           <a:prstGeom prst="rect">
             <a:avLst/>
@@ -11518,7 +11515,7 @@
         </p:nvSpPr>
         <p:spPr>
           <a:xfrm>
-            <a:off x="6400800" y="1828800"/>
+            <a:off x="6400800" y="1737360"/>
             <a:ext cx="4983480" cy="411480"/>
           </a:xfrm>
           <a:prstGeom prst="rect">
@@ -11557,8 +11554,8 @@
         </p:nvSpPr>
         <p:spPr>
           <a:xfrm>
-            <a:off x="6400800" y="2331720"/>
-            <a:ext cx="4983480" cy="1417320"/>
+            <a:off x="6400800" y="2240280"/>
+            <a:ext cx="4983480" cy="1508760"/>
           </a:xfrm>
           <a:prstGeom prst="rect">
             <a:avLst/>
@@ -11571,20 +11568,17 @@
           <a:lstStyle/>
           <a:p>
             <a:pPr indent="0" marL="0">
-              <a:spcAft>
-                <a:spcPts val="800"/>
-              </a:spcAft>
-              <a:buNone/>
-            </a:pPr>
-            <a:r>
-              <a:rPr lang="en-US" sz="1600" dirty="0">
+              <a:buNone/>
+            </a:pPr>
+            <a:r>
+              <a:rPr lang="en-US" sz="1400" dirty="0">
                 <a:solidFill>
                   <a:schemeClr val="tx2"/>
                 </a:solidFill>
               </a:rPr>
-              <a:t>Knows the whole map and replays the racing plan. It ignores the sensors so small errors grow until it leaves the line.</a:t>
-            </a:r>
-            <a:endParaRPr lang="en-US" sz="1600" dirty="0"/>
+              <a:t>Replays the racing plan open loop. Logic: the planner sets a speed for every point and the map gives the curvature, so the turn rate is speed times curvature. The robot tracks its own distance along the route. The sensors are ignored, so any drift grows until it derails.</a:t>
+            </a:r>
+            <a:endParaRPr lang="en-US" sz="1400" dirty="0"/>
           </a:p>
         </p:txBody>
       </p:sp>
@@ -11596,8 +11590,8 @@
         </p:nvSpPr>
         <p:spPr>
           <a:xfrm>
-            <a:off x="548640" y="4114800"/>
-            <a:ext cx="5440680" cy="2286000"/>
+            <a:off x="548640" y="4069080"/>
+            <a:ext cx="5440680" cy="2377440"/>
           </a:xfrm>
           <a:prstGeom prst="rect">
             <a:avLst/>
@@ -11621,7 +11615,7 @@
         </p:nvSpPr>
         <p:spPr>
           <a:xfrm>
-            <a:off x="777240" y="4297680"/>
+            <a:off x="777240" y="4251960"/>
             <a:ext cx="4983480" cy="411480"/>
           </a:xfrm>
           <a:prstGeom prst="rect">
@@ -11660,8 +11654,8 @@
         </p:nvSpPr>
         <p:spPr>
           <a:xfrm>
-            <a:off x="777240" y="4800600"/>
-            <a:ext cx="4983480" cy="1417320"/>
+            <a:off x="777240" y="4754880"/>
+            <a:ext cx="4983480" cy="1508760"/>
           </a:xfrm>
           <a:prstGeom prst="rect">
             <a:avLst/>
@@ -11674,20 +11668,17 @@
           <a:lstStyle/>
           <a:p>
             <a:pPr indent="0" marL="0">
-              <a:spcAft>
-                <a:spcPts val="800"/>
-              </a:spcAft>
-              <a:buNone/>
-            </a:pPr>
-            <a:r>
-              <a:rPr lang="en-US" sz="1600" dirty="0">
+              <a:buNone/>
+            </a:pPr>
+            <a:r>
+              <a:rPr lang="en-US" sz="1400" dirty="0">
                 <a:solidFill>
                   <a:schemeClr val="tx2"/>
                 </a:solidFill>
               </a:rPr>
-              <a:t>Replays the racing plan and uses the sensors to fix drift. This is our fastest and most reliable mode.</a:t>
-            </a:r>
-            <a:endParaRPr lang="en-US" sz="1600" dirty="0"/>
+              <a:t>Same plan as blind, plus a correction. Logic: the same feed forward, with a PID on the sensed line offset that steers the robot back. The sensors also bridge short gaps and show the finish, where the tape ends.</a:t>
+            </a:r>
+            <a:endParaRPr lang="en-US" sz="1400" dirty="0"/>
           </a:p>
         </p:txBody>
       </p:sp>
@@ -11699,8 +11690,8 @@
         </p:nvSpPr>
         <p:spPr>
           <a:xfrm>
-            <a:off x="6172200" y="4114800"/>
-            <a:ext cx="5440680" cy="2286000"/>
+            <a:off x="6172200" y="4069080"/>
+            <a:ext cx="5440680" cy="2377440"/>
           </a:xfrm>
           <a:prstGeom prst="rect">
             <a:avLst/>
@@ -11724,7 +11715,7 @@
         </p:nvSpPr>
         <p:spPr>
           <a:xfrm>
-            <a:off x="6400800" y="4297680"/>
+            <a:off x="6400800" y="4251960"/>
             <a:ext cx="4983480" cy="411480"/>
           </a:xfrm>
           <a:prstGeom prst="rect">
@@ -11763,8 +11754,8 @@
         </p:nvSpPr>
         <p:spPr>
           <a:xfrm>
-            <a:off x="6400800" y="4800600"/>
-            <a:ext cx="4983480" cy="1417320"/>
+            <a:off x="6400800" y="4754880"/>
+            <a:ext cx="4983480" cy="1508760"/>
           </a:xfrm>
           <a:prstGeom prst="rect">
             <a:avLst/>
@@ -11777,20 +11768,17 @@
           <a:lstStyle/>
           <a:p>
             <a:pPr indent="0" marL="0">
-              <a:spcAft>
-                <a:spcPts val="800"/>
-              </a:spcAft>
-              <a:buNone/>
-            </a:pPr>
-            <a:r>
-              <a:rPr lang="en-US" sz="1600" dirty="0">
+              <a:buNone/>
+            </a:pPr>
+            <a:r>
+              <a:rPr lang="en-US" sz="1400" dirty="0">
                 <a:solidFill>
                   <a:schemeClr val="tx2"/>
                 </a:solidFill>
               </a:rPr>
-              <a:t>Uses two sensor rows and wheel encoders. It measures the curve it is in and sets speed from grip. No map needed.</a:t>
-            </a:r>
-            <a:endParaRPr lang="en-US" sz="1600" dirty="0"/>
+              <a:t>No map needed. Logic: the front and rear rows give the line direction, and the encoders give the robot turn rate. Together they give the curvature of the bend. Speed is set to the square root of grip over curvature, capped at 0.4 m/s and rate limited like the plan.</a:t>
+            </a:r>
+            <a:endParaRPr lang="en-US" sz="1400" dirty="0"/>
           </a:p>
         </p:txBody>
       </p:sp>

</xml_diff>

<commit_message>
Rebuild the presentation with the updated results
Claude-Session: https://claude.ai/code/session_01KU8aCf3zzAsNP6oUkmmfPM
</commit_message>
<xml_diff>
--- a/deck/line_follower_blueprint.pptx
+++ b/deck/line_follower_blueprint.pptx
@@ -130,19 +130,19 @@
   <p:extLst>
     <p:ext uri="{521415D9-36F7-43E2-AB2F-B90AF26B5E84}">
       <p14:sectionLst xmlns:p14="http://schemas.microsoft.com/office/powerpoint/2010/main">
-        <p14:section name="Introduction" id="{f4256794-e9ae-774b-8c0e-87ea7118d70f}">
+        <p14:section name="Introduction" id="{2eae0cf5-f285-4ccc-9f7a-ef1eeef7a473}">
           <p14:sldIdLst>
             <p14:sldId id="256"/>
           </p14:sldIdLst>
         </p14:section>
-        <p14:section name="Our idea" id="{d623312d-0b7f-e52d-88a7-b32da3370187}">
+        <p14:section name="Our idea" id="{5574b8fa-c8b8-c5fb-c649-7a4612ab21c6}">
           <p14:sldIdLst>
             <p14:sldId id="257"/>
             <p14:sldId id="258"/>
             <p14:sldId id="259"/>
           </p14:sldIdLst>
         </p14:section>
-        <p14:section name="The four ways to drive" id="{089c0e9f-94d6-2501-c944-4d074c1303e1}">
+        <p14:section name="The four ways to drive" id="{4721c12b-77c0-688b-7d85-45f57ea9fabc}">
           <p14:sldIdLst>
             <p14:sldId id="260"/>
             <p14:sldId id="261"/>
@@ -152,7 +152,7 @@
             <p14:sldId id="265"/>
           </p14:sldIdLst>
         </p14:section>
-        <p14:section name="The engineering, in plain words" id="{298e653c-1045-64a8-f802-4377312b4a27}">
+        <p14:section name="The engineering, in plain words" id="{af36dcd7-9e3b-2374-cd88-4443c4eeb940}">
           <p14:sldIdLst>
             <p14:sldId id="266"/>
             <p14:sldId id="267"/>
@@ -166,7 +166,7 @@
             <p14:sldId id="275"/>
           </p14:sldIdLst>
         </p14:section>
-        <p14:section name="Why it matters" id="{3d21d4ed-5fbe-0df3-3c84-33f95300d9e6}">
+        <p14:section name="Why it matters" id="{a71ffec0-2256-a9b8-53c8-1204207e5e8b}">
           <p14:sldIdLst>
             <p14:sldId id="276"/>
             <p14:sldId id="277"/>
@@ -4660,7 +4660,7 @@
                           <a:ea typeface="Calibri" pitchFamily="34" charset="-122"/>
                           <a:cs typeface="Calibri" pitchFamily="34" charset="-120"/>
                         </a:rPr>
-                        <a:t>7.20</a:t>
+                        <a:t>7.11</a:t>
                       </a:r>
                       <a:endParaRPr lang="en-US" sz="1400" dirty="0">
                         <a:latin typeface="Calibri" charset="0"/>
@@ -5052,7 +5052,7 @@
                           <a:ea typeface="Calibri" pitchFamily="34" charset="-122"/>
                           <a:cs typeface="Calibri" pitchFamily="34" charset="-120"/>
                         </a:rPr>
-                        <a:t>4.28</a:t>
+                        <a:t>4.35</a:t>
                       </a:r>
                       <a:endParaRPr lang="en-US" sz="1400" dirty="0">
                         <a:latin typeface="Calibri" charset="0"/>
@@ -5444,7 +5444,7 @@
                           <a:ea typeface="Calibri" pitchFamily="34" charset="-122"/>
                           <a:cs typeface="Calibri" pitchFamily="34" charset="-120"/>
                         </a:rPr>
-                        <a:t>5.47</a:t>
+                        <a:t>5.57</a:t>
                       </a:r>
                       <a:endParaRPr lang="en-US" sz="1400" dirty="0">
                         <a:latin typeface="Calibri" charset="0"/>
@@ -5836,7 +5836,7 @@
                           <a:ea typeface="Calibri" pitchFamily="34" charset="-122"/>
                           <a:cs typeface="Calibri" pitchFamily="34" charset="-120"/>
                         </a:rPr>
-                        <a:t>4.29</a:t>
+                        <a:t>4.22</a:t>
                       </a:r>
                       <a:endParaRPr lang="en-US" sz="1400" dirty="0">
                         <a:latin typeface="Calibri" charset="0"/>
@@ -6228,7 +6228,7 @@
                           <a:ea typeface="Calibri" pitchFamily="34" charset="-122"/>
                           <a:cs typeface="Calibri" pitchFamily="34" charset="-120"/>
                         </a:rPr>
-                        <a:t>4.17</a:t>
+                        <a:t>4.28</a:t>
                       </a:r>
                       <a:endParaRPr lang="en-US" sz="1400" dirty="0">
                         <a:latin typeface="Calibri" charset="0"/>
@@ -6620,7 +6620,7 @@
                           <a:ea typeface="Calibri" pitchFamily="34" charset="-122"/>
                           <a:cs typeface="Calibri" pitchFamily="34" charset="-120"/>
                         </a:rPr>
-                        <a:t>6.68</a:t>
+                        <a:t>6.63</a:t>
                       </a:r>
                       <a:endParaRPr lang="en-US" sz="1400" dirty="0">
                         <a:latin typeface="Calibri" charset="0"/>

</xml_diff>